<commit_message>
Update Mitsue Project decks (EN + JP) with current project state
- Refresh dates, energy framing (biomass CHP primary), advisor
  roster, funding stack (target ¥192M, ¥0 secured), and phase
  budgets to match the EVM plan and funding flowchart.
- Soften the data-center site story: Koryukan is one candidate
  among other vacant buildings/factories, not a settled site.
- Add the revenue-recycling narrative: biomass CHP + AI DC revenue
  funds higher landowner payouts, co-op mechanized equipment, and
  opens a buyer for C/D-grade wood (co-op currently only moves A/B).
- Correct slide 9: no formal meeting with the Mayor is planned —
  it's a document drop-off to keep him informed, not a meeting.
- Drop stale Joi Ito reference from speaker notes (removed as
  advisor 2026-06-17).
- Fix footer page counts and section numbering (§ order, /12).

Co-Authored-By: Claude Sonnet 5 <noreply@anthropic.com>
</commit_message>
<xml_diff>
--- a/decks/Mitsue Project Presentation - 日本語.pptx
+++ b/decks/Mitsue Project Presentation - 日本語.pptx
@@ -2764,7 +2764,7 @@
                 </a:solidFill>
                 <a:latin typeface="Arial"/>
               </a:rPr>
-              <a:t>5</a:t>
+              <a:t>9</a:t>
             </a:r>
             <a:r>
               <a:rPr lang="zh-CN" sz="2000" b="0" u="none" strike="noStrike">
@@ -2791,7 +2791,7 @@
                 </a:solidFill>
                 <a:latin typeface="Arial"/>
               </a:rPr>
-              <a:t>段階、意図的に静かに進めています。御杖村副村長との初回面談、地元林業組合との初回面談は完了。定款と実行計画は起草済み。段階と資金ゲートの図表も公開済み。アドバイザーとして二名が確定——伊藤穰一氏とレイ・オジー氏。次の</a:t>
+              <a:t>意図的に静かに進めています。副村長、御杖観光・林業組合、モアツリーズ／天川との面談は完了。定款・実行計画・EVM計画（総予算¥220M）を起草済み。GX地域共創脱炭素化補助金の問合せも提出済みです。アドバイザー体制は11名に拡大——うち無償の弁護士3名を含みます。村長とは正式面談ではなく、資料をお届けして状況をお伝えしています。NAISTでの講演も2027年1月13日に確定しました。次の</a:t>
             </a:r>
             <a:r>
               <a:rPr lang="en-US" sz="2000" b="0" u="none" strike="noStrike">
@@ -2809,7 +2809,7 @@
                 </a:solidFill>
                 <a:latin typeface="Arial"/>
               </a:rPr>
-              <a:t>日——日本人共同創設者へのアプローチ、村長との面談、奈良の行政書士への相談、二言語版定款の最終化です。</a:t>
+              <a:t>日でやるべきことは、日本人共同創設者探しの決着、一般社団法人Mitsue-itの細則確定、GX地域共創第2回応募（締切11月30日）です。</a:t>
             </a:r>
             <a:endParaRPr lang="en-US" sz="2000" b="0" u="none" strike="noStrike">
               <a:solidFill>
@@ -3682,7 +3682,7 @@
                 <a:latin typeface="Noto Sans JP"/>
                 <a:ea typeface="Noto Sans JP"/>
               </a:rPr>
-              <a:t>5</a:t>
+              <a:t>9</a:t>
             </a:r>
             <a:r>
               <a:rPr lang="zh-CN" sz="1800" b="0" u="none" strike="noStrike" spc="108">
@@ -3978,7 +3978,7 @@
                 <a:latin typeface="Noto Sans JP"/>
                 <a:ea typeface="Noto Sans JP"/>
               </a:rPr>
-              <a:t>01 / 11</a:t>
+              <a:t>01 / 12</a:t>
             </a:r>
             <a:endParaRPr lang="en-US" sz="1800" b="0" u="none" strike="noStrike">
               <a:solidFill>
@@ -4046,7 +4046,7 @@
                 <a:latin typeface="Noto Sans JP"/>
                 <a:ea typeface="Noto Sans JP"/>
               </a:rPr>
-              <a:t>· EV</a:t>
+              <a:t>· バイオマス</a:t>
             </a:r>
             <a:r>
               <a:rPr lang="zh-CN" sz="1800" b="0" u="none" strike="noStrike" spc="71">
@@ -4056,7 +4056,7 @@
                 <a:latin typeface="Noto Sans JP"/>
                 <a:ea typeface="Noto Sans JP"/>
               </a:rPr>
-              <a:t>電力 </a:t>
+              <a:t>CHP </a:t>
             </a:r>
             <a:r>
               <a:rPr lang="en-US" sz="1800" b="0" u="none" strike="noStrike" spc="71">
@@ -4825,7 +4825,7 @@
                 <a:latin typeface="Noto Sans JP"/>
                 <a:ea typeface="Noto Sans JP"/>
               </a:rPr>
-              <a:t>¥0–0.5M</a:t>
+              <a:t>¥0.25M</a:t>
             </a:r>
             <a:endParaRPr lang="en-US" sz="1800" b="0" u="none" strike="noStrike">
               <a:solidFill>
@@ -5106,7 +5106,7 @@
                 <a:latin typeface="Noto Sans JP"/>
                 <a:ea typeface="Noto Sans JP"/>
               </a:rPr>
-              <a:t>¥3–8M</a:t>
+              <a:t>¥5.5M</a:t>
             </a:r>
             <a:endParaRPr lang="en-US" sz="1800" b="0" u="none" strike="noStrike">
               <a:solidFill>
@@ -5387,7 +5387,7 @@
                 <a:latin typeface="Noto Sans JP"/>
                 <a:ea typeface="Noto Sans JP"/>
               </a:rPr>
-              <a:t>¥15–30M</a:t>
+              <a:t>¥22.25M</a:t>
             </a:r>
             <a:endParaRPr lang="en-US" sz="1800" b="0" u="none" strike="noStrike">
               <a:solidFill>
@@ -5668,7 +5668,7 @@
                 <a:latin typeface="Noto Sans JP"/>
                 <a:ea typeface="Noto Sans JP"/>
               </a:rPr>
-              <a:t>¥80–200M</a:t>
+              <a:t>¥177M</a:t>
             </a:r>
             <a:endParaRPr lang="en-US" sz="1800" b="0" u="none" strike="noStrike">
               <a:solidFill>
@@ -6093,7 +6093,7 @@
                 <a:latin typeface="Noto Sans JP"/>
                 <a:ea typeface="Noto Sans JP"/>
               </a:rPr>
-              <a:t>G3 · ¥80–200M</a:t>
+              <a:t>G3 · ¥120–290M</a:t>
             </a:r>
             <a:endParaRPr lang="en-US" sz="1800" b="0" u="none" strike="noStrike">
               <a:solidFill>
@@ -6219,7 +6219,7 @@
                 <a:latin typeface="Noto Sans JP"/>
                 <a:ea typeface="Noto Sans JP"/>
               </a:rPr>
-              <a:t>五層資金スタック </a:t>
+              <a:t>五層資金スタック</a:t>
             </a:r>
             <a:r>
               <a:rPr lang="en-US" sz="1800" b="0" u="none" strike="noStrike" spc="145">
@@ -6229,7 +6229,7 @@
                 <a:latin typeface="Noto Sans JP"/>
                 <a:ea typeface="Noto Sans JP"/>
               </a:rPr>
-              <a:t>· 3</a:t>
+              <a:t> · 目標 ≈ </a:t>
             </a:r>
             <a:r>
               <a:rPr lang="zh-CN" sz="1800" b="0" u="none" strike="noStrike" spc="145">
@@ -6239,7 +6239,7 @@
                 <a:latin typeface="Noto Sans JP"/>
                 <a:ea typeface="Noto Sans JP"/>
               </a:rPr>
-              <a:t>年目目標 ≈ </a:t>
+              <a:t>¥192M</a:t>
             </a:r>
             <a:r>
               <a:rPr lang="en-US" sz="1800" b="0" u="none" strike="noStrike" spc="145">
@@ -6249,7 +6249,7 @@
                 <a:latin typeface="Noto Sans JP"/>
                 <a:ea typeface="Noto Sans JP"/>
               </a:rPr>
-              <a:t>¥134M</a:t>
+              <a:t> · 調達済み ¥0</a:t>
             </a:r>
             <a:endParaRPr lang="en-US" sz="1800" b="0" u="none" strike="noStrike">
               <a:solidFill>
@@ -6467,7 +6467,7 @@
                 <a:latin typeface="Noto Sans JP"/>
                 <a:ea typeface="Noto Sans JP"/>
               </a:rPr>
-              <a:t>1</a:t>
+              <a:t/>
             </a:r>
             <a:r>
               <a:rPr lang="zh-CN" sz="1800" b="0" u="none" strike="noStrike">
@@ -6477,7 +6477,7 @@
                 <a:latin typeface="Noto Sans JP"/>
                 <a:ea typeface="Noto Sans JP"/>
               </a:rPr>
-              <a:t>年目</a:t>
+              <a:t>目標</a:t>
             </a:r>
             <a:endParaRPr lang="en-US" sz="1800" b="0" u="none" strike="noStrike">
               <a:solidFill>
@@ -6535,7 +6535,7 @@
                 <a:latin typeface="Noto Sans JP"/>
                 <a:ea typeface="Noto Sans JP"/>
               </a:rPr>
-              <a:t>3</a:t>
+              <a:t/>
             </a:r>
             <a:r>
               <a:rPr lang="zh-CN" sz="1800" b="0" u="none" strike="noStrike">
@@ -6545,7 +6545,7 @@
                 <a:latin typeface="Noto Sans JP"/>
                 <a:ea typeface="Noto Sans JP"/>
               </a:rPr>
-              <a:t>年目</a:t>
+              <a:t>調達済み</a:t>
             </a:r>
             <a:endParaRPr lang="en-US" sz="1800" b="0" u="none" strike="noStrike">
               <a:solidFill>
@@ -6765,7 +6765,7 @@
                 <a:latin typeface="Courier New"/>
                 <a:ea typeface="Courier New"/>
               </a:rPr>
-              <a:t>¥3M</a:t>
+              <a:t>¥6M</a:t>
             </a:r>
             <a:endParaRPr lang="en-US" sz="1800" b="0" u="none" strike="noStrike">
               <a:solidFill>
@@ -6823,7 +6823,7 @@
                 <a:latin typeface="Courier New"/>
                 <a:ea typeface="Courier New"/>
               </a:rPr>
-              <a:t>¥1M</a:t>
+              <a:t>¥0</a:t>
             </a:r>
             <a:endParaRPr lang="en-US" sz="1800" b="0" u="none" strike="noStrike">
               <a:solidFill>
@@ -7043,7 +7043,7 @@
                 <a:latin typeface="Courier New"/>
                 <a:ea typeface="Courier New"/>
               </a:rPr>
-              <a:t>¥5M</a:t>
+              <a:t>¥115M</a:t>
             </a:r>
             <a:endParaRPr lang="en-US" sz="1800" b="0" u="none" strike="noStrike">
               <a:solidFill>
@@ -7101,7 +7101,7 @@
                 <a:latin typeface="Courier New"/>
                 <a:ea typeface="Courier New"/>
               </a:rPr>
-              <a:t>¥80M</a:t>
+              <a:t>¥0</a:t>
             </a:r>
             <a:endParaRPr lang="en-US" sz="1800" b="0" u="none" strike="noStrike">
               <a:solidFill>
@@ -7321,7 +7321,7 @@
                 <a:latin typeface="Courier New"/>
                 <a:ea typeface="Courier New"/>
               </a:rPr>
-              <a:t>¥3M</a:t>
+              <a:t>¥33M</a:t>
             </a:r>
             <a:endParaRPr lang="en-US" sz="1800" b="0" u="none" strike="noStrike">
               <a:solidFill>
@@ -7379,7 +7379,7 @@
                 <a:latin typeface="Courier New"/>
                 <a:ea typeface="Courier New"/>
               </a:rPr>
-              <a:t>¥20M</a:t>
+              <a:t>¥0</a:t>
             </a:r>
             <a:endParaRPr lang="en-US" sz="1800" b="0" u="none" strike="noStrike">
               <a:solidFill>
@@ -7599,7 +7599,7 @@
                 <a:latin typeface="Courier New"/>
                 <a:ea typeface="Courier New"/>
               </a:rPr>
-              <a:t>¥0</a:t>
+              <a:t>¥35M</a:t>
             </a:r>
             <a:endParaRPr lang="en-US" sz="1800" b="0" u="none" strike="noStrike">
               <a:solidFill>
@@ -7657,7 +7657,7 @@
                 <a:latin typeface="Courier New"/>
                 <a:ea typeface="Courier New"/>
               </a:rPr>
-              <a:t>¥30M</a:t>
+              <a:t>¥0</a:t>
             </a:r>
             <a:endParaRPr lang="en-US" sz="1800" b="0" u="none" strike="noStrike">
               <a:solidFill>
@@ -7877,7 +7877,7 @@
                 <a:latin typeface="Courier New"/>
                 <a:ea typeface="Courier New"/>
               </a:rPr>
-              <a:t>¥0</a:t>
+              <a:t>¥3M</a:t>
             </a:r>
             <a:endParaRPr lang="en-US" sz="1800" b="0" u="none" strike="noStrike">
               <a:solidFill>
@@ -7935,7 +7935,7 @@
                 <a:latin typeface="Courier New"/>
                 <a:ea typeface="Courier New"/>
               </a:rPr>
-              <a:t>¥3M</a:t>
+              <a:t>¥0</a:t>
             </a:r>
             <a:endParaRPr lang="en-US" sz="1800" b="0" u="none" strike="noStrike">
               <a:solidFill>
@@ -8109,7 +8109,7 @@
                 <a:latin typeface="Courier New"/>
                 <a:ea typeface="Courier New"/>
               </a:rPr>
-              <a:t>¥11M</a:t>
+              <a:t>¥192M</a:t>
             </a:r>
             <a:endParaRPr lang="en-US" sz="1800" b="0" u="none" strike="noStrike">
               <a:solidFill>
@@ -8167,7 +8167,7 @@
                 <a:latin typeface="Courier New"/>
                 <a:ea typeface="Courier New"/>
               </a:rPr>
-              <a:t>¥134M</a:t>
+              <a:t>¥0</a:t>
             </a:r>
             <a:endParaRPr lang="en-US" sz="1800" b="0" u="none" strike="noStrike">
               <a:solidFill>
@@ -8691,7 +8691,7 @@
                 <a:latin typeface="Noto Sans JP"/>
                 <a:ea typeface="Noto Sans JP"/>
               </a:rPr>
-              <a:t>10 / 11</a:t>
+              <a:t>10 / 12</a:t>
             </a:r>
             <a:endParaRPr lang="en-US" sz="1800" b="0" u="none" strike="noStrike">
               <a:solidFill>
@@ -9041,7 +9041,7 @@
                 <a:latin typeface="Noto Sans JP"/>
                 <a:ea typeface="Noto Sans JP"/>
               </a:rPr>
-              <a:t>§ 11 · </a:t>
+              <a:t>§ 10 · </a:t>
             </a:r>
             <a:r>
               <a:rPr lang="zh-CN" sz="1800" b="0" u="none" strike="noStrike" spc="108">
@@ -10155,7 +10155,7 @@
                 <a:latin typeface="Noto Sans JP"/>
                 <a:ea typeface="Noto Sans JP"/>
               </a:rPr>
-              <a:t>12 / 12</a:t>
+              <a:t>11 / 12</a:t>
             </a:r>
             <a:endParaRPr lang="en-US" sz="1800" b="0" u="none" strike="noStrike">
               <a:solidFill>
@@ -10573,7 +10573,7 @@
                 <a:latin typeface="Noto Sans JP"/>
                 <a:ea typeface="Noto Sans JP"/>
               </a:rPr>
-              <a:t>§ 10 · </a:t>
+              <a:t>§ 11 · </a:t>
             </a:r>
             <a:r>
               <a:rPr lang="zh-CN" sz="1800" b="0" u="none" strike="noStrike" spc="108">
@@ -11643,7 +11643,7 @@
                 <a:latin typeface="Noto Sans JP"/>
                 <a:ea typeface="Noto Sans JP"/>
               </a:rPr>
-              <a:t>11 / 11</a:t>
+              <a:t>12 / 12</a:t>
             </a:r>
             <a:endParaRPr lang="en-US" sz="1800" b="0" u="none" strike="noStrike">
               <a:solidFill>
@@ -13074,7 +13074,7 @@
                 <a:latin typeface="Noto Sans JP"/>
                 <a:ea typeface="Noto Sans JP"/>
               </a:rPr>
-              <a:t>02 / 11</a:t>
+              <a:t>02 / 12</a:t>
             </a:r>
             <a:endParaRPr lang="en-US" sz="1800" b="0" u="none" strike="noStrike">
               <a:solidFill>
@@ -14166,7 +14166,7 @@
                 <a:latin typeface="Noto Serif JP"/>
                 <a:ea typeface="Noto Serif JP"/>
               </a:rPr>
-              <a:t>学校はただ放置されている。</a:t>
+              <a:t>村の空き施設はただ放置されている。</a:t>
             </a:r>
             <a:endParaRPr lang="en-US" sz="2400" b="0" u="none" strike="noStrike">
               <a:solidFill>
@@ -14224,7 +14224,7 @@
                 <a:latin typeface="Noto Sans JP"/>
                 <a:ea typeface="Noto Sans JP"/>
               </a:rPr>
-              <a:t>空き校舎は人口減少自治体の維持費負担。生産的な再利用で、地域の拠点に変わります。</a:t>
+              <a:t>空き校舎や工場は人口減少自治体の維持費負担。生産的な再利用で、地域の拠点に変わります。</a:t>
             </a:r>
             <a:endParaRPr lang="en-US" sz="1800" b="0" u="none" strike="noStrike">
               <a:solidFill>
@@ -14534,7 +14534,7 @@
                 <a:latin typeface="Noto Sans JP"/>
                 <a:ea typeface="Noto Sans JP"/>
               </a:rPr>
-              <a:t>03 / 11</a:t>
+              <a:t>03 / 12</a:t>
             </a:r>
             <a:endParaRPr lang="en-US" sz="1800" b="0" u="none" strike="noStrike">
               <a:solidFill>
@@ -15738,7 +15738,7 @@
                 <a:latin typeface="Noto Sans JP"/>
                 <a:ea typeface="Noto Sans JP"/>
               </a:rPr>
-              <a:t>旧校舎を再利用。村が所有できる規模で。</a:t>
+              <a:t>村が所有できる小規模拠点——複数の空き施設を検討中。</a:t>
             </a:r>
             <a:endParaRPr lang="en-US" sz="1800" b="0" u="none" strike="noStrike">
               <a:solidFill>
@@ -15798,7 +15798,7 @@
                 <a:latin typeface="Noto Sans JP"/>
                 <a:ea typeface="Noto Sans JP"/>
               </a:rPr>
-              <a:t>04 / 11</a:t>
+              <a:t>04 / 12</a:t>
             </a:r>
             <a:endParaRPr lang="en-US" sz="1800" b="0" u="none" strike="noStrike">
               <a:solidFill>
@@ -16370,7 +16370,7 @@
                 <a:latin typeface="Noto Sans JP"/>
                 <a:ea typeface="Noto Sans JP"/>
               </a:rPr>
-              <a:t>伐採した杉は無駄になりません——村の主要なバイオマス燃料となります。森が自らの再生費用を生み出します。</a:t>
+              <a:t>伐採した杉は無駄になりません——バイオマスCHPとデータセンターの燃料になります。その収益で地主への支払いを引き上げ、組合の機械化設備にも充てます。</a:t>
             </a:r>
             <a:endParaRPr lang="en-US" sz="2100" b="0" u="none" strike="noStrike">
               <a:solidFill>
@@ -17294,7 +17294,7 @@
                 <a:latin typeface="Noto Sans JP"/>
                 <a:ea typeface="Noto Sans JP"/>
               </a:rPr>
-              <a:t>05 / 11</a:t>
+              <a:t>05 / 12</a:t>
             </a:r>
             <a:endParaRPr lang="en-US" sz="1800" b="0" u="none" strike="noStrike">
               <a:solidFill>
@@ -17955,7 +17955,7 @@
                 <a:latin typeface="Noto Sans JP"/>
                 <a:ea typeface="Noto Sans JP"/>
               </a:rPr>
-              <a:t>06 / 11</a:t>
+              <a:t>06 / 12</a:t>
             </a:r>
             <a:endParaRPr lang="en-US" sz="1800" b="0" u="none" strike="noStrike">
               <a:solidFill>
@@ -18521,7 +18521,7 @@
                 <a:latin typeface="Noto Sans JP"/>
                 <a:ea typeface="Noto Sans JP"/>
               </a:rPr>
-              <a:t>御杖体験交流館（活用可能な地域の空き交流施設）を、エネルギー効率の高い小規模エッジ計算施設として活用。フェーズ</a:t>
+              <a:t>候補地：御杖体験交流館（活用可能な地域の交流施設）や旧工場など、他の空き施設も検討中。エネルギー効率の高い小規模エッジ計算施設として</a:t>
             </a:r>
             <a:r>
               <a:rPr lang="en-US" sz="1900" b="0" u="none" strike="noStrike">
@@ -18531,7 +18531,7 @@
                 <a:latin typeface="Noto Sans JP"/>
                 <a:ea typeface="Noto Sans JP"/>
               </a:rPr>
-              <a:t>2</a:t>
+              <a:t/>
             </a:r>
             <a:r>
               <a:rPr lang="zh-CN" sz="1900" b="0" u="none" strike="noStrike">
@@ -18541,7 +18541,7 @@
                 <a:latin typeface="Noto Sans JP"/>
                 <a:ea typeface="Noto Sans JP"/>
               </a:rPr>
-              <a:t>では村内の空き工場へ拡張します。</a:t>
+              <a:t>活用します。</a:t>
             </a:r>
             <a:r>
               <a:rPr lang="en-US" sz="1900" b="0" u="none" strike="noStrike">
@@ -19222,7 +19222,7 @@
                 <a:latin typeface="Noto Sans JP"/>
                 <a:ea typeface="Noto Sans JP"/>
               </a:rPr>
-              <a:t>07 / 11</a:t>
+              <a:t>07 / 12</a:t>
             </a:r>
             <a:endParaRPr lang="en-US" sz="1800" b="0" u="none" strike="noStrike">
               <a:solidFill>
@@ -19904,7 +19904,7 @@
                 <a:latin typeface="Noto Sans JP"/>
                 <a:ea typeface="Noto Sans JP"/>
               </a:rPr>
-              <a:t>↳ 通年の有給林業業務</a:t>
+              <a:t>↳ 通年の有給林業業務＋組合設備の更新</a:t>
             </a:r>
             <a:endParaRPr lang="en-US" sz="1800" b="0" u="none" strike="noStrike">
               <a:solidFill>
@@ -20032,7 +20032,7 @@
                 <a:latin typeface="Noto Sans JP"/>
                 <a:ea typeface="Noto Sans JP"/>
               </a:rPr>
-              <a:t>↳ 控えめで、説明責任があり、村が所有する</a:t>
+              <a:t>↳ 地主への支払い向上＋C/D級材の買い手</a:t>
             </a:r>
             <a:endParaRPr lang="en-US" sz="1800" b="0" u="none" strike="noStrike">
               <a:solidFill>
@@ -20652,7 +20652,7 @@
                 <a:latin typeface="Noto Sans JP"/>
                 <a:ea typeface="Noto Sans JP"/>
               </a:rPr>
-              <a:t>08 / 11</a:t>
+              <a:t>08 / 12</a:t>
             </a:r>
             <a:endParaRPr lang="en-US" sz="1800" b="0" u="none" strike="noStrike">
               <a:solidFill>
@@ -21058,7 +21058,7 @@
                 <a:latin typeface="Noto Sans JP"/>
                 <a:ea typeface="Noto Sans JP"/>
               </a:rPr>
-              <a:t>5</a:t>
+              <a:t>9</a:t>
             </a:r>
             <a:r>
               <a:rPr lang="zh-CN" sz="1800" b="0" u="none" strike="noStrike" spc="108">
@@ -21322,7 +21322,7 @@
                 <a:latin typeface="Noto Sans JP"/>
                 <a:ea typeface="Noto Sans JP"/>
               </a:rPr>
-              <a:t>段階は、地域での信頼構築、創設チーム編成、定款の清書。自己資金、</a:t>
+              <a:t>段階は、地域での信頼構築、アドバイザー体制の強化、資金調達先の選定。自己資金、</a:t>
             </a:r>
             <a:r>
               <a:rPr lang="en-US" sz="2100" b="0" u="none" strike="noStrike">
@@ -21332,7 +21332,7 @@
                 <a:latin typeface="Noto Sans JP"/>
                 <a:ea typeface="Noto Sans JP"/>
               </a:rPr>
-              <a:t>¥0–0.5M</a:t>
+              <a:t>¥0–0.25M</a:t>
             </a:r>
             <a:r>
               <a:rPr lang="zh-CN" sz="2100" b="0" u="none" strike="noStrike">
@@ -21839,7 +21839,7 @@
                 <a:latin typeface="Noto Sans JP"/>
                 <a:ea typeface="Noto Sans JP"/>
               </a:rPr>
-              <a:t>地元林業組合との初回面談</a:t>
+              <a:t>御杖観光・林業組合・モアツリーズ／天川との面談</a:t>
             </a:r>
             <a:r>
               <a:rPr lang="en-US" sz="1800" b="0" u="none" strike="noStrike">
@@ -21859,7 +21859,7 @@
                 <a:latin typeface="Noto Sans JP"/>
                 <a:ea typeface="Noto Sans JP"/>
               </a:rPr>
-              <a:t>年初頭</a:t>
+              <a:t>年5〜8月</a:t>
             </a:r>
             <a:r>
               <a:rPr lang="en-US" sz="1800" b="0" u="none" strike="noStrike">
@@ -21901,7 +21901,7 @@
                 <a:latin typeface="Noto Sans JP"/>
                 <a:ea typeface="Noto Sans JP"/>
               </a:rPr>
-              <a:t>創設定款と実行計画を起草</a:t>
+              <a:t>創設定款・実行計画・EVM計画を起草（総予算¥220M）</a:t>
             </a:r>
             <a:endParaRPr lang="en-US" sz="1800" b="0" u="none" strike="noStrike">
               <a:solidFill>
@@ -21933,7 +21933,7 @@
                 <a:latin typeface="Noto Sans JP"/>
                 <a:ea typeface="Noto Sans JP"/>
               </a:rPr>
-              <a:t>段階・資金ゲート図表を公開</a:t>
+              <a:t>GX地域共創脱炭素化補助金の問合せを提出（2026年8月）</a:t>
             </a:r>
             <a:endParaRPr lang="en-US" sz="1800" b="0" u="none" strike="noStrike">
               <a:solidFill>
@@ -21965,7 +21965,7 @@
                 <a:latin typeface="Noto Sans JP"/>
                 <a:ea typeface="Noto Sans JP"/>
               </a:rPr>
-              <a:t>アドバイザー就任</a:t>
+              <a:t>アドバイザー </a:t>
             </a:r>
             <a:r>
               <a:rPr lang="en-US" sz="1800" b="0" u="none" strike="noStrike">
@@ -21975,7 +21975,7 @@
                 <a:latin typeface="Noto Sans JP"/>
                 <a:ea typeface="Noto Sans JP"/>
               </a:rPr>
-              <a:t>:</a:t>
+              <a:t>11</a:t>
             </a:r>
             <a:r>
               <a:rPr lang="zh-CN" sz="1800" b="0" u="none" strike="noStrike">
@@ -21985,7 +21985,7 @@
                 <a:latin typeface="Noto Sans JP"/>
                 <a:ea typeface="Noto Sans JP"/>
               </a:rPr>
-              <a:t>レイ・オジー、堂目卓生</a:t>
+              <a:t>名体制に拡大（無償弁護士3名含む）</a:t>
             </a:r>
             <a:endParaRPr lang="en-US" sz="1800" b="0" u="none" strike="noStrike">
               <a:solidFill>
@@ -22185,7 +22185,7 @@
                 <a:latin typeface="Noto Sans JP"/>
                 <a:ea typeface="Noto Sans JP"/>
               </a:rPr>
-              <a:t>村長との正式面談の調整</a:t>
+              <a:t>村長へ資料をお届けし、状況を共有</a:t>
             </a:r>
             <a:endParaRPr lang="en-US" sz="1800" b="0" u="none" strike="noStrike">
               <a:solidFill>
@@ -22217,7 +22217,7 @@
                 <a:latin typeface="Noto Sans JP"/>
                 <a:ea typeface="Noto Sans JP"/>
               </a:rPr>
-              <a:t>一般社団法人の細則起草</a:t>
+              <a:t>一般社団法人Mitsue-itの細則起草</a:t>
             </a:r>
             <a:endParaRPr lang="en-US" sz="1800" b="0" u="none" strike="noStrike">
               <a:solidFill>
@@ -22469,7 +22469,7 @@
                 <a:latin typeface="Noto Sans JP"/>
                 <a:ea typeface="Noto Sans JP"/>
               </a:rPr>
-              <a:t>村長との非公式面談</a:t>
+              <a:t>村役場との静かな関係構築を継続</a:t>
             </a:r>
             <a:endParaRPr lang="en-US" sz="1800" b="0" u="none" strike="noStrike">
               <a:solidFill>
@@ -22501,7 +22501,7 @@
                 <a:latin typeface="Noto Sans JP"/>
                 <a:ea typeface="Noto Sans JP"/>
               </a:rPr>
-              <a:t>行政書士への初期相談</a:t>
+              <a:t>GX地域共創第2回応募（締切2026年11月30日）</a:t>
             </a:r>
             <a:endParaRPr lang="en-US" sz="1800" b="0" u="none" strike="noStrike">
               <a:solidFill>
@@ -22533,7 +22533,7 @@
                 <a:latin typeface="Noto Sans JP"/>
                 <a:ea typeface="Noto Sans JP"/>
               </a:rPr>
-              <a:t>二言語</a:t>
+              <a:t>NAISTセミナーの準備（確定：</a:t>
             </a:r>
             <a:r>
               <a:rPr lang="en-US" sz="1800" b="0" u="none" strike="noStrike">
@@ -22543,7 +22543,7 @@
                 <a:latin typeface="Noto Sans JP"/>
                 <a:ea typeface="Noto Sans JP"/>
               </a:rPr>
-              <a:t>2</a:t>
+              <a:t>2027</a:t>
             </a:r>
             <a:r>
               <a:rPr lang="zh-CN" sz="1800" b="0" u="none" strike="noStrike">
@@ -22553,7 +22553,7 @@
                 <a:latin typeface="Noto Sans JP"/>
                 <a:ea typeface="Noto Sans JP"/>
               </a:rPr>
-              <a:t>ページの定款を最終化</a:t>
+              <a:t>年1月13日）</a:t>
             </a:r>
             <a:endParaRPr lang="en-US" sz="1800" b="0" u="none" strike="noStrike">
               <a:solidFill>
@@ -22611,7 +22611,7 @@
                 <a:latin typeface="Noto Sans JP"/>
                 <a:ea typeface="Noto Sans JP"/>
               </a:rPr>
-              <a:t>09 / 11</a:t>
+              <a:t>09 / 12</a:t>
             </a:r>
             <a:endParaRPr lang="en-US" sz="1800" b="0" u="none" strike="noStrike">
               <a:solidFill>
@@ -22719,7 +22719,7 @@
                 <a:latin typeface="Noto Sans JP"/>
                 <a:ea typeface="Noto Sans JP"/>
               </a:rPr>
-              <a:t>3</a:t>
+              <a:t>6</a:t>
             </a:r>
             <a:r>
               <a:rPr lang="zh-CN" sz="1800" b="0" u="none" strike="noStrike" spc="71">

</xml_diff>